<commit_message>
5.20 CSS 수업 준비
</commit_message>
<xml_diff>
--- a/material/[SeSAC_YDP_6] 03_CSS.pptx
+++ b/material/[SeSAC_YDP_6] 03_CSS.pptx
@@ -217,7 +217,7 @@
           <a:p>
             <a:fld id="{2EF3F159-7250-4DD4-91C2-13B35D56E1AF}" type="datetimeFigureOut">
               <a:rPr lang="ko-KR" altLang="en-US" smtClean="0"/>
-              <a:t>2024-05-17</a:t>
+              <a:t>2024-05-20</a:t>
             </a:fld>
             <a:endParaRPr lang="ko-KR" altLang="en-US"/>
           </a:p>
@@ -1948,7 +1948,24 @@
             </a:r>
             <a:r>
               <a:rPr lang="en-US" altLang="ko-KR" dirty="0"/>
-              <a:t>?</a:t>
+              <a:t>? </a:t>
+            </a:r>
+          </a:p>
+          <a:p>
+            <a:endParaRPr lang="en-US" altLang="ko-KR" dirty="0"/>
+          </a:p>
+          <a:p>
+            <a:r>
+              <a:rPr lang="en-US" altLang="ko-KR" dirty="0"/>
+              <a:t>Apple </a:t>
+            </a:r>
+            <a:r>
+              <a:rPr lang="ko-KR" altLang="en-US" dirty="0"/>
+              <a:t>사이트 접속</a:t>
+            </a:r>
+            <a:r>
+              <a:rPr lang="en-US" altLang="ko-KR" dirty="0"/>
+              <a:t>.</a:t>
             </a:r>
             <a:endParaRPr lang="ko-KR" altLang="en-US" dirty="0"/>
           </a:p>
@@ -6289,7 +6306,7 @@
           <a:p>
             <a:fld id="{0F78D9C4-20C1-4B15-A116-16DC77AD9A1E}" type="datetime1">
               <a:rPr lang="ko-KR" altLang="en-US" smtClean="0"/>
-              <a:t>2024-05-17</a:t>
+              <a:t>2024-05-20</a:t>
             </a:fld>
             <a:endParaRPr lang="ko-KR" altLang="en-US"/>
           </a:p>
@@ -6508,7 +6525,7 @@
           <a:p>
             <a:fld id="{81C09065-B160-4C23-B986-5A3C55D6AFAF}" type="datetime1">
               <a:rPr lang="ko-KR" altLang="en-US" smtClean="0"/>
-              <a:t>2024-05-17</a:t>
+              <a:t>2024-05-20</a:t>
             </a:fld>
             <a:endParaRPr lang="ko-KR" altLang="en-US"/>
           </a:p>
@@ -6822,7 +6839,7 @@
           <a:p>
             <a:fld id="{C66F1034-6CCC-40D2-8922-9671B2240F59}" type="datetime1">
               <a:rPr lang="ko-KR" altLang="en-US" smtClean="0"/>
-              <a:t>2024-05-17</a:t>
+              <a:t>2024-05-20</a:t>
             </a:fld>
             <a:endParaRPr lang="ko-KR" altLang="en-US"/>
           </a:p>
@@ -7105,7 +7122,7 @@
           <a:p>
             <a:fld id="{C1B50917-1ED7-489B-87EB-30911B0F206C}" type="datetime1">
               <a:rPr lang="ko-KR" altLang="en-US" smtClean="0"/>
-              <a:t>2024-05-17</a:t>
+              <a:t>2024-05-20</a:t>
             </a:fld>
             <a:endParaRPr lang="ko-KR" altLang="en-US"/>
           </a:p>
@@ -7250,7 +7267,7 @@
           <a:p>
             <a:fld id="{6881C1A1-740B-40EC-B341-AFFFABB3121A}" type="datetime1">
               <a:rPr lang="ko-KR" altLang="en-US" smtClean="0"/>
-              <a:t>2024-05-17</a:t>
+              <a:t>2024-05-20</a:t>
             </a:fld>
             <a:endParaRPr lang="ko-KR" altLang="en-US"/>
           </a:p>
@@ -7378,14 +7395,14 @@
           </p:cNvPr>
           <p:cNvCxnSpPr>
             <a:cxnSpLocks/>
-            <a:stCxn id="8" idx="3"/>
+            <a:stCxn id="8" idx="0"/>
           </p:cNvCxnSpPr>
           <p:nvPr/>
         </p:nvCxnSpPr>
         <p:spPr>
           <a:xfrm flipV="1">
-            <a:off x="5447565" y="2492214"/>
-            <a:ext cx="4188804" cy="1972171"/>
+            <a:off x="3345594" y="2492214"/>
+            <a:ext cx="6290775" cy="1188640"/>
           </a:xfrm>
           <a:prstGeom prst="straightConnector1">
             <a:avLst/>
@@ -7849,7 +7866,7 @@
           <a:p>
             <a:fld id="{0F78D9C4-20C1-4B15-A116-16DC77AD9A1E}" type="datetime1">
               <a:rPr lang="ko-KR" altLang="en-US" smtClean="0"/>
-              <a:t>2024-05-17</a:t>
+              <a:t>2024-05-20</a:t>
             </a:fld>
             <a:endParaRPr lang="ko-KR" altLang="en-US"/>
           </a:p>
@@ -8366,7 +8383,7 @@
           <a:p>
             <a:fld id="{0F78D9C4-20C1-4B15-A116-16DC77AD9A1E}" type="datetime1">
               <a:rPr lang="ko-KR" altLang="en-US" smtClean="0"/>
-              <a:t>2024-05-17</a:t>
+              <a:t>2024-05-20</a:t>
             </a:fld>
             <a:endParaRPr lang="ko-KR" altLang="en-US"/>
           </a:p>
@@ -8556,7 +8573,7 @@
           <a:p>
             <a:fld id="{0F78D9C4-20C1-4B15-A116-16DC77AD9A1E}" type="datetime1">
               <a:rPr lang="ko-KR" altLang="en-US" smtClean="0"/>
-              <a:t>2024-05-17</a:t>
+              <a:t>2024-05-20</a:t>
             </a:fld>
             <a:endParaRPr lang="ko-KR" altLang="en-US"/>
           </a:p>
@@ -8649,7 +8666,7 @@
             </a:r>
             <a:r>
               <a:rPr lang="ko-KR" altLang="en-US" dirty="0"/>
-              <a:t>태그는 어느 곳에 사용될 까요</a:t>
+              <a:t>태그는 어느 곳에 사용될까요</a:t>
             </a:r>
             <a:r>
               <a:rPr lang="en-US" altLang="ko-KR" dirty="0"/>
@@ -8806,7 +8823,7 @@
           <a:p>
             <a:fld id="{0F78D9C4-20C1-4B15-A116-16DC77AD9A1E}" type="datetime1">
               <a:rPr lang="ko-KR" altLang="en-US" smtClean="0"/>
-              <a:t>2024-05-17</a:t>
+              <a:t>2024-05-20</a:t>
             </a:fld>
             <a:endParaRPr lang="ko-KR" altLang="en-US"/>
           </a:p>
@@ -9188,7 +9205,7 @@
           <a:p>
             <a:fld id="{0F78D9C4-20C1-4B15-A116-16DC77AD9A1E}" type="datetime1">
               <a:rPr lang="ko-KR" altLang="en-US" smtClean="0"/>
-              <a:t>2024-05-17</a:t>
+              <a:t>2024-05-20</a:t>
             </a:fld>
             <a:endParaRPr lang="ko-KR" altLang="en-US"/>
           </a:p>
@@ -9359,7 +9376,7 @@
           <a:p>
             <a:fld id="{0F78D9C4-20C1-4B15-A116-16DC77AD9A1E}" type="datetime1">
               <a:rPr lang="ko-KR" altLang="en-US" smtClean="0"/>
-              <a:t>2024-05-17</a:t>
+              <a:t>2024-05-20</a:t>
             </a:fld>
             <a:endParaRPr lang="ko-KR" altLang="en-US"/>
           </a:p>
@@ -9735,7 +9752,7 @@
           <a:p>
             <a:fld id="{0F78D9C4-20C1-4B15-A116-16DC77AD9A1E}" type="datetime1">
               <a:rPr lang="ko-KR" altLang="en-US" smtClean="0"/>
-              <a:t>2024-05-17</a:t>
+              <a:t>2024-05-20</a:t>
             </a:fld>
             <a:endParaRPr lang="ko-KR" altLang="en-US"/>
           </a:p>
@@ -10102,7 +10119,7 @@
           <a:p>
             <a:fld id="{0F78D9C4-20C1-4B15-A116-16DC77AD9A1E}" type="datetime1">
               <a:rPr lang="ko-KR" altLang="en-US" smtClean="0"/>
-              <a:t>2024-05-17</a:t>
+              <a:t>2024-05-20</a:t>
             </a:fld>
             <a:endParaRPr lang="ko-KR" altLang="en-US"/>
           </a:p>
@@ -10620,7 +10637,7 @@
           <a:p>
             <a:fld id="{9411292F-9570-41D6-B1EF-AD0662BD256A}" type="datetime1">
               <a:rPr lang="ko-KR" altLang="en-US" smtClean="0"/>
-              <a:t>2024-05-17</a:t>
+              <a:t>2024-05-20</a:t>
             </a:fld>
             <a:endParaRPr lang="ko-KR" altLang="en-US"/>
           </a:p>
@@ -10747,7 +10764,7 @@
           <a:p>
             <a:fld id="{0F78D9C4-20C1-4B15-A116-16DC77AD9A1E}" type="datetime1">
               <a:rPr lang="ko-KR" altLang="en-US" smtClean="0"/>
-              <a:t>2024-05-17</a:t>
+              <a:t>2024-05-20</a:t>
             </a:fld>
             <a:endParaRPr lang="ko-KR" altLang="en-US"/>
           </a:p>

</xml_diff>